<commit_message>
R1 self-play, preso, results update
</commit_message>
<xml_diff>
--- a/newcomb_deck.pptx
+++ b/newcomb_deck.pptx
@@ -13,6 +13,7 @@
     <p:sldId id="261" r:id="rId12"/>
     <p:sldId id="262" r:id="rId13"/>
     <p:sldId id="263" r:id="rId14"/>
+    <p:sldId id="264" r:id="rId15"/>
   </p:sldIdLst>
   <p:sldSz cx="12191695" cy="6858000" type="screen4x3"/>
   <p:notesSz cx="6858000" cy="9144000"/>
@@ -3088,6 +3089,14 @@
 <file path=ppt/slides/slide1.xml><?xml version="1.0" encoding="utf-8"?>
 <p:sld xmlns:a="http://schemas.openxmlformats.org/drawingml/2006/main" xmlns:p="http://schemas.openxmlformats.org/presentationml/2006/main" xmlns:r="http://schemas.openxmlformats.org/officeDocument/2006/relationships">
   <p:cSld>
+    <p:bg>
+      <p:bgPr>
+        <a:solidFill>
+          <a:srgbClr val="0A0A0A"/>
+        </a:solidFill>
+        <a:effectLst/>
+      </p:bgPr>
+    </p:bg>
     <p:spTree>
       <p:nvGrpSpPr>
         <p:cNvPr id="1" name=""/>
@@ -3120,19 +3129,154 @@
             <a:pPr>
               <a:defRPr sz="2600" b="1">
                 <a:solidFill>
-                  <a:srgbClr val="1F2D3D"/>
+                  <a:srgbClr val="E8E8E8"/>
                 </a:solidFill>
               </a:defRPr>
             </a:pPr>
             <a:r>
-              <a:t>The claim</a:t>
+              <a:t>Newcomb's problem — the recipe</a:t>
             </a:r>
           </a:p>
           <a:p>
             <a:pPr>
               <a:defRPr sz="1300" i="1">
                 <a:solidFill>
-                  <a:srgbClr val="555555"/>
+                  <a:srgbClr val="9AA4AF"/>
+                </a:solidFill>
+              </a:defRPr>
+            </a:pPr>
+            <a:r>
+              <a:t>how to read every chart that follows</a:t>
+            </a:r>
+          </a:p>
+        </p:txBody>
+      </p:sp>
+      <p:pic>
+        <p:nvPicPr>
+          <p:cNvPr id="3" name="Picture 2" descr="recipe.png"/>
+          <p:cNvPicPr>
+            <a:picLocks noChangeAspect="1"/>
+          </p:cNvPicPr>
+          <p:nvPr/>
+        </p:nvPicPr>
+        <p:blipFill>
+          <a:blip r:embed="rId2"/>
+          <a:stretch>
+            <a:fillRect/>
+          </a:stretch>
+        </p:blipFill>
+        <p:spPr>
+          <a:xfrm>
+            <a:off x="502920" y="1325880"/>
+            <a:ext cx="11155680" cy="4946315"/>
+          </a:xfrm>
+          <a:prstGeom prst="rect">
+            <a:avLst/>
+          </a:prstGeom>
+        </p:spPr>
+      </p:pic>
+      <p:sp>
+        <p:nvSpPr>
+          <p:cNvPr id="4" name="TextBox 3"/>
+          <p:cNvSpPr txBox="1"/>
+          <p:nvPr/>
+        </p:nvSpPr>
+        <p:spPr>
+          <a:xfrm>
+            <a:off x="548640" y="6263640"/>
+            <a:ext cx="11155680" cy="457200"/>
+          </a:xfrm>
+          <a:prstGeom prst="rect">
+            <a:avLst/>
+          </a:prstGeom>
+          <a:noFill/>
+        </p:spPr>
+        <p:txBody>
+          <a:bodyPr wrap="square">
+            <a:spAutoFit/>
+          </a:bodyPr>
+          <a:lstStyle/>
+          <a:p>
+            <a:pPr>
+              <a:spcAft>
+                <a:spcPts val="400"/>
+              </a:spcAft>
+              <a:defRPr sz="1200">
+                <a:solidFill>
+                  <a:srgbClr val="E8E8E8"/>
+                </a:solidFill>
+              </a:defRPr>
+            </a:pPr>
+            <a:r>
+              <a:t>• We sweep the stated accuracy p and watch the one-box (K) rate: a flat line = recitation/disposition; a step at p* = the model is actually doing the expected-value reasoning.</a:t>
+            </a:r>
+          </a:p>
+        </p:txBody>
+      </p:sp>
+    </p:spTree>
+  </p:cSld>
+  <p:clrMapOvr>
+    <a:masterClrMapping/>
+  </p:clrMapOvr>
+</p:sld>
+</file>
+
+<file path=ppt/slides/slide2.xml><?xml version="1.0" encoding="utf-8"?>
+<p:sld xmlns:a="http://schemas.openxmlformats.org/drawingml/2006/main" xmlns:p="http://schemas.openxmlformats.org/presentationml/2006/main" xmlns:r="http://schemas.openxmlformats.org/officeDocument/2006/relationships">
+  <p:cSld>
+    <p:bg>
+      <p:bgPr>
+        <a:solidFill>
+          <a:srgbClr val="0A0A0A"/>
+        </a:solidFill>
+        <a:effectLst/>
+      </p:bgPr>
+    </p:bg>
+    <p:spTree>
+      <p:nvGrpSpPr>
+        <p:cNvPr id="1" name=""/>
+        <p:cNvGrpSpPr/>
+        <p:nvPr/>
+      </p:nvGrpSpPr>
+      <p:grpSpPr/>
+      <p:sp>
+        <p:nvSpPr>
+          <p:cNvPr id="2" name="TextBox 1"/>
+          <p:cNvSpPr txBox="1"/>
+          <p:nvPr/>
+        </p:nvSpPr>
+        <p:spPr>
+          <a:xfrm>
+            <a:off x="411480" y="201168"/>
+            <a:ext cx="11338560" cy="868680"/>
+          </a:xfrm>
+          <a:prstGeom prst="rect">
+            <a:avLst/>
+          </a:prstGeom>
+          <a:noFill/>
+        </p:spPr>
+        <p:txBody>
+          <a:bodyPr wrap="square">
+            <a:spAutoFit/>
+          </a:bodyPr>
+          <a:lstStyle/>
+          <a:p>
+            <a:pPr>
+              <a:defRPr sz="2600" b="1">
+                <a:solidFill>
+                  <a:srgbClr val="E8E8E8"/>
+                </a:solidFill>
+              </a:defRPr>
+            </a:pPr>
+            <a:r>
+              <a:t>The claim</a:t>
+            </a:r>
+          </a:p>
+          <a:p>
+            <a:pPr>
+              <a:defRPr sz="1300" i="1">
+                <a:solidFill>
+                  <a:srgbClr val="9AA4AF"/>
                 </a:solidFill>
               </a:defRPr>
             </a:pPr>
@@ -3167,7 +3311,7 @@
             <a:pPr>
               <a:defRPr sz="1900" b="1">
                 <a:solidFill>
-                  <a:srgbClr val="1F2D3D"/>
+                  <a:srgbClr val="E8E8E8"/>
                 </a:solidFill>
               </a:defRPr>
             </a:pPr>
@@ -3179,7 +3323,7 @@
             <a:pPr>
               <a:defRPr sz="1400">
                 <a:solidFill>
-                  <a:srgbClr val="555555"/>
+                  <a:srgbClr val="9AA4AF"/>
                 </a:solidFill>
               </a:defRPr>
             </a:pPr>
@@ -3221,9 +3365,17 @@
 </p:sld>
 </file>
 
-<file path=ppt/slides/slide2.xml><?xml version="1.0" encoding="utf-8"?>
+<file path=ppt/slides/slide3.xml><?xml version="1.0" encoding="utf-8"?>
 <p:sld xmlns:a="http://schemas.openxmlformats.org/drawingml/2006/main" xmlns:p="http://schemas.openxmlformats.org/presentationml/2006/main" xmlns:r="http://schemas.openxmlformats.org/officeDocument/2006/relationships">
   <p:cSld>
+    <p:bg>
+      <p:bgPr>
+        <a:solidFill>
+          <a:srgbClr val="0A0A0A"/>
+        </a:solidFill>
+        <a:effectLst/>
+      </p:bgPr>
+    </p:bg>
     <p:spTree>
       <p:nvGrpSpPr>
         <p:cNvPr id="1" name=""/>
@@ -3256,7 +3408,7 @@
             <a:pPr>
               <a:defRPr sz="2600" b="1">
                 <a:solidFill>
-                  <a:srgbClr val="1F2D3D"/>
+                  <a:srgbClr val="E8E8E8"/>
                 </a:solidFill>
               </a:defRPr>
             </a:pPr>
@@ -3283,7 +3435,7 @@
         <p:spPr>
           <a:xfrm>
             <a:off x="274320" y="1097280"/>
-            <a:ext cx="7680960" cy="5308307"/>
+            <a:ext cx="7680960" cy="4994516"/>
           </a:xfrm>
           <a:prstGeom prst="rect">
             <a:avLst/>
@@ -3305,11 +3457,11 @@
             <a:avLst/>
           </a:prstGeom>
           <a:solidFill>
-            <a:srgbClr val="EEF3FB"/>
+            <a:srgbClr val="14202E"/>
           </a:solidFill>
           <a:ln w="19050">
             <a:solidFill>
-              <a:srgbClr val="2E5C8A"/>
+              <a:srgbClr val="4F9DE0"/>
             </a:solidFill>
           </a:ln>
         </p:spPr>
@@ -3322,7 +3474,7 @@
             <a:pPr>
               <a:defRPr sz="1350">
                 <a:solidFill>
-                  <a:srgbClr val="1F2D3D"/>
+                  <a:srgbClr val="E8E8E8"/>
                 </a:solidFill>
               </a:defRPr>
             </a:pPr>
@@ -3355,9 +3507,17 @@
 </p:sld>
 </file>
 
-<file path=ppt/slides/slide3.xml><?xml version="1.0" encoding="utf-8"?>
+<file path=ppt/slides/slide4.xml><?xml version="1.0" encoding="utf-8"?>
 <p:sld xmlns:a="http://schemas.openxmlformats.org/drawingml/2006/main" xmlns:p="http://schemas.openxmlformats.org/presentationml/2006/main" xmlns:r="http://schemas.openxmlformats.org/officeDocument/2006/relationships">
   <p:cSld>
+    <p:bg>
+      <p:bgPr>
+        <a:solidFill>
+          <a:srgbClr val="0A0A0A"/>
+        </a:solidFill>
+        <a:effectLst/>
+      </p:bgPr>
+    </p:bg>
     <p:spTree>
       <p:nvGrpSpPr>
         <p:cNvPr id="1" name=""/>
@@ -3390,7 +3550,7 @@
             <a:pPr>
               <a:defRPr sz="2600" b="1">
                 <a:solidFill>
-                  <a:srgbClr val="1F2D3D"/>
+                  <a:srgbClr val="E8E8E8"/>
                 </a:solidFill>
               </a:defRPr>
             </a:pPr>
@@ -3428,7 +3588,7 @@
               </a:spcAft>
               <a:defRPr sz="1400">
                 <a:solidFill>
-                  <a:srgbClr val="1F2D3D"/>
+                  <a:srgbClr val="E8E8E8"/>
                 </a:solidFill>
               </a:defRPr>
             </a:pPr>
@@ -3453,7 +3613,7 @@
         <a:graphic>
           <a:graphicData uri="http://schemas.openxmlformats.org/drawingml/2006/table">
             <a:tbl>
-              <a:tblPr firstRow="1" bandRow="1">
+              <a:tblPr>
                 <a:tableStyleId>{5C22544A-7EE6-4342-B048-85BDC9FD1C3A}</a:tableStyleId>
               </a:tblPr>
               <a:tblGrid>
@@ -3483,7 +3643,7 @@
                   </a:txBody>
                   <a:tcPr anchor="ctr">
                     <a:solidFill>
-                      <a:srgbClr val="2E5C8A"/>
+                      <a:srgbClr val="4F9DE0"/>
                     </a:solidFill>
                   </a:tcPr>
                 </a:tc>
@@ -3506,7 +3666,7 @@
                   </a:txBody>
                   <a:tcPr anchor="ctr">
                     <a:solidFill>
-                      <a:srgbClr val="2E5C8A"/>
+                      <a:srgbClr val="4F9DE0"/>
                     </a:solidFill>
                   </a:tcPr>
                 </a:tc>
@@ -3529,7 +3689,7 @@
                   </a:txBody>
                   <a:tcPr anchor="ctr">
                     <a:solidFill>
-                      <a:srgbClr val="2E5C8A"/>
+                      <a:srgbClr val="4F9DE0"/>
                     </a:solidFill>
                   </a:tcPr>
                 </a:tc>
@@ -3552,7 +3712,7 @@
                   </a:txBody>
                   <a:tcPr anchor="ctr">
                     <a:solidFill>
-                      <a:srgbClr val="2E5C8A"/>
+                      <a:srgbClr val="4F9DE0"/>
                     </a:solidFill>
                   </a:tcPr>
                 </a:tc>
@@ -3575,7 +3735,7 @@
                   </a:txBody>
                   <a:tcPr anchor="ctr">
                     <a:solidFill>
-                      <a:srgbClr val="2E5C8A"/>
+                      <a:srgbClr val="4F9DE0"/>
                     </a:solidFill>
                   </a:tcPr>
                 </a:tc>
@@ -3587,9 +3747,9 @@
                     <a:lstStyle/>
                     <a:p>
                       <a:pPr algn="l">
-                        <a:defRPr sz="1250">
+                        <a:defRPr sz="1250" b="0">
                           <a:solidFill>
-                            <a:srgbClr val="1F2D3D"/>
+                            <a:srgbClr val="E8E8E8"/>
                           </a:solidFill>
                         </a:defRPr>
                       </a:pPr>
@@ -3598,7 +3758,11 @@
                       </a:r>
                     </a:p>
                   </a:txBody>
-                  <a:tcPr anchor="ctr"/>
+                  <a:tcPr anchor="ctr">
+                    <a:solidFill>
+                      <a:srgbClr val="161A21"/>
+                    </a:solidFill>
+                  </a:tcPr>
                 </a:tc>
                 <a:tc>
                   <a:txBody>
@@ -3606,9 +3770,9 @@
                     <a:lstStyle/>
                     <a:p>
                       <a:pPr algn="ctr">
-                        <a:defRPr sz="1250">
+                        <a:defRPr sz="1250" b="0">
                           <a:solidFill>
-                            <a:srgbClr val="1F2D3D"/>
+                            <a:srgbClr val="E8E8E8"/>
                           </a:solidFill>
                         </a:defRPr>
                       </a:pPr>
@@ -3617,7 +3781,11 @@
                       </a:r>
                     </a:p>
                   </a:txBody>
-                  <a:tcPr anchor="ctr"/>
+                  <a:tcPr anchor="ctr">
+                    <a:solidFill>
+                      <a:srgbClr val="161A21"/>
+                    </a:solidFill>
+                  </a:tcPr>
                 </a:tc>
                 <a:tc>
                   <a:txBody>
@@ -3625,9 +3793,9 @@
                     <a:lstStyle/>
                     <a:p>
                       <a:pPr algn="ctr">
-                        <a:defRPr sz="1250">
+                        <a:defRPr sz="1250" b="0">
                           <a:solidFill>
-                            <a:srgbClr val="1F2D3D"/>
+                            <a:srgbClr val="E8E8E8"/>
                           </a:solidFill>
                         </a:defRPr>
                       </a:pPr>
@@ -3636,7 +3804,11 @@
                       </a:r>
                     </a:p>
                   </a:txBody>
-                  <a:tcPr anchor="ctr"/>
+                  <a:tcPr anchor="ctr">
+                    <a:solidFill>
+                      <a:srgbClr val="161A21"/>
+                    </a:solidFill>
+                  </a:tcPr>
                 </a:tc>
                 <a:tc>
                   <a:txBody>
@@ -3644,9 +3816,9 @@
                     <a:lstStyle/>
                     <a:p>
                       <a:pPr algn="ctr">
-                        <a:defRPr sz="1250">
+                        <a:defRPr sz="1250" b="0">
                           <a:solidFill>
-                            <a:srgbClr val="1F2D3D"/>
+                            <a:srgbClr val="E8E8E8"/>
                           </a:solidFill>
                         </a:defRPr>
                       </a:pPr>
@@ -3655,7 +3827,11 @@
                       </a:r>
                     </a:p>
                   </a:txBody>
-                  <a:tcPr anchor="ctr"/>
+                  <a:tcPr anchor="ctr">
+                    <a:solidFill>
+                      <a:srgbClr val="161A21"/>
+                    </a:solidFill>
+                  </a:tcPr>
                 </a:tc>
                 <a:tc>
                   <a:txBody>
@@ -3663,9 +3839,9 @@
                     <a:lstStyle/>
                     <a:p>
                       <a:pPr algn="ctr">
-                        <a:defRPr sz="1250">
+                        <a:defRPr sz="1250" b="0">
                           <a:solidFill>
-                            <a:srgbClr val="1F2D3D"/>
+                            <a:srgbClr val="E8E8E8"/>
                           </a:solidFill>
                         </a:defRPr>
                       </a:pPr>
@@ -3674,7 +3850,11 @@
                       </a:r>
                     </a:p>
                   </a:txBody>
-                  <a:tcPr anchor="ctr"/>
+                  <a:tcPr anchor="ctr">
+                    <a:solidFill>
+                      <a:srgbClr val="161A21"/>
+                    </a:solidFill>
+                  </a:tcPr>
                 </a:tc>
               </a:tr>
               <a:tr h="365760">
@@ -3684,9 +3864,9 @@
                     <a:lstStyle/>
                     <a:p>
                       <a:pPr algn="l">
-                        <a:defRPr sz="1250">
+                        <a:defRPr sz="1250" b="0">
                           <a:solidFill>
-                            <a:srgbClr val="1F2D3D"/>
+                            <a:srgbClr val="E8E8E8"/>
                           </a:solidFill>
                         </a:defRPr>
                       </a:pPr>
@@ -3695,7 +3875,11 @@
                       </a:r>
                     </a:p>
                   </a:txBody>
-                  <a:tcPr anchor="ctr"/>
+                  <a:tcPr anchor="ctr">
+                    <a:solidFill>
+                      <a:srgbClr val="161A21"/>
+                    </a:solidFill>
+                  </a:tcPr>
                 </a:tc>
                 <a:tc>
                   <a:txBody>
@@ -3703,9 +3887,9 @@
                     <a:lstStyle/>
                     <a:p>
                       <a:pPr algn="ctr">
-                        <a:defRPr sz="1250">
+                        <a:defRPr sz="1250" b="0">
                           <a:solidFill>
-                            <a:srgbClr val="1F2D3D"/>
+                            <a:srgbClr val="E8E8E8"/>
                           </a:solidFill>
                         </a:defRPr>
                       </a:pPr>
@@ -3714,7 +3898,11 @@
                       </a:r>
                     </a:p>
                   </a:txBody>
-                  <a:tcPr anchor="ctr"/>
+                  <a:tcPr anchor="ctr">
+                    <a:solidFill>
+                      <a:srgbClr val="161A21"/>
+                    </a:solidFill>
+                  </a:tcPr>
                 </a:tc>
                 <a:tc>
                   <a:txBody>
@@ -3722,9 +3910,9 @@
                     <a:lstStyle/>
                     <a:p>
                       <a:pPr algn="ctr">
-                        <a:defRPr sz="1250">
+                        <a:defRPr sz="1250" b="0">
                           <a:solidFill>
-                            <a:srgbClr val="1F2D3D"/>
+                            <a:srgbClr val="E8E8E8"/>
                           </a:solidFill>
                         </a:defRPr>
                       </a:pPr>
@@ -3733,7 +3921,11 @@
                       </a:r>
                     </a:p>
                   </a:txBody>
-                  <a:tcPr anchor="ctr"/>
+                  <a:tcPr anchor="ctr">
+                    <a:solidFill>
+                      <a:srgbClr val="161A21"/>
+                    </a:solidFill>
+                  </a:tcPr>
                 </a:tc>
                 <a:tc>
                   <a:txBody>
@@ -3741,9 +3933,9 @@
                     <a:lstStyle/>
                     <a:p>
                       <a:pPr algn="ctr">
-                        <a:defRPr sz="1250">
+                        <a:defRPr sz="1250" b="0">
                           <a:solidFill>
-                            <a:srgbClr val="1F2D3D"/>
+                            <a:srgbClr val="E8E8E8"/>
                           </a:solidFill>
                         </a:defRPr>
                       </a:pPr>
@@ -3752,7 +3944,11 @@
                       </a:r>
                     </a:p>
                   </a:txBody>
-                  <a:tcPr anchor="ctr"/>
+                  <a:tcPr anchor="ctr">
+                    <a:solidFill>
+                      <a:srgbClr val="161A21"/>
+                    </a:solidFill>
+                  </a:tcPr>
                 </a:tc>
                 <a:tc>
                   <a:txBody>
@@ -3760,9 +3956,9 @@
                     <a:lstStyle/>
                     <a:p>
                       <a:pPr algn="ctr">
-                        <a:defRPr sz="1250">
+                        <a:defRPr sz="1250" b="0">
                           <a:solidFill>
-                            <a:srgbClr val="1F2D3D"/>
+                            <a:srgbClr val="E8E8E8"/>
                           </a:solidFill>
                         </a:defRPr>
                       </a:pPr>
@@ -3771,7 +3967,11 @@
                       </a:r>
                     </a:p>
                   </a:txBody>
-                  <a:tcPr anchor="ctr"/>
+                  <a:tcPr anchor="ctr">
+                    <a:solidFill>
+                      <a:srgbClr val="161A21"/>
+                    </a:solidFill>
+                  </a:tcPr>
                 </a:tc>
               </a:tr>
               <a:tr h="365760">
@@ -3781,9 +3981,9 @@
                     <a:lstStyle/>
                     <a:p>
                       <a:pPr algn="l">
-                        <a:defRPr sz="1250">
+                        <a:defRPr sz="1250" b="0">
                           <a:solidFill>
-                            <a:srgbClr val="1F2D3D"/>
+                            <a:srgbClr val="E8E8E8"/>
                           </a:solidFill>
                         </a:defRPr>
                       </a:pPr>
@@ -3792,7 +3992,11 @@
                       </a:r>
                     </a:p>
                   </a:txBody>
-                  <a:tcPr anchor="ctr"/>
+                  <a:tcPr anchor="ctr">
+                    <a:solidFill>
+                      <a:srgbClr val="161A21"/>
+                    </a:solidFill>
+                  </a:tcPr>
                 </a:tc>
                 <a:tc>
                   <a:txBody>
@@ -3800,9 +4004,9 @@
                     <a:lstStyle/>
                     <a:p>
                       <a:pPr algn="ctr">
-                        <a:defRPr sz="1250">
+                        <a:defRPr sz="1250" b="0">
                           <a:solidFill>
-                            <a:srgbClr val="1F2D3D"/>
+                            <a:srgbClr val="E8E8E8"/>
                           </a:solidFill>
                         </a:defRPr>
                       </a:pPr>
@@ -3811,7 +4015,11 @@
                       </a:r>
                     </a:p>
                   </a:txBody>
-                  <a:tcPr anchor="ctr"/>
+                  <a:tcPr anchor="ctr">
+                    <a:solidFill>
+                      <a:srgbClr val="161A21"/>
+                    </a:solidFill>
+                  </a:tcPr>
                 </a:tc>
                 <a:tc>
                   <a:txBody>
@@ -3819,9 +4027,9 @@
                     <a:lstStyle/>
                     <a:p>
                       <a:pPr algn="ctr">
-                        <a:defRPr sz="1250">
+                        <a:defRPr sz="1250" b="0">
                           <a:solidFill>
-                            <a:srgbClr val="1F2D3D"/>
+                            <a:srgbClr val="E8E8E8"/>
                           </a:solidFill>
                         </a:defRPr>
                       </a:pPr>
@@ -3830,7 +4038,11 @@
                       </a:r>
                     </a:p>
                   </a:txBody>
-                  <a:tcPr anchor="ctr"/>
+                  <a:tcPr anchor="ctr">
+                    <a:solidFill>
+                      <a:srgbClr val="161A21"/>
+                    </a:solidFill>
+                  </a:tcPr>
                 </a:tc>
                 <a:tc>
                   <a:txBody>
@@ -3838,9 +4050,9 @@
                     <a:lstStyle/>
                     <a:p>
                       <a:pPr algn="ctr">
-                        <a:defRPr sz="1250">
+                        <a:defRPr sz="1250" b="0">
                           <a:solidFill>
-                            <a:srgbClr val="1F2D3D"/>
+                            <a:srgbClr val="E8E8E8"/>
                           </a:solidFill>
                         </a:defRPr>
                       </a:pPr>
@@ -3849,7 +4061,11 @@
                       </a:r>
                     </a:p>
                   </a:txBody>
-                  <a:tcPr anchor="ctr"/>
+                  <a:tcPr anchor="ctr">
+                    <a:solidFill>
+                      <a:srgbClr val="161A21"/>
+                    </a:solidFill>
+                  </a:tcPr>
                 </a:tc>
                 <a:tc>
                   <a:txBody>
@@ -3857,9 +4073,9 @@
                     <a:lstStyle/>
                     <a:p>
                       <a:pPr algn="ctr">
-                        <a:defRPr sz="1250">
+                        <a:defRPr sz="1250" b="0">
                           <a:solidFill>
-                            <a:srgbClr val="1F2D3D"/>
+                            <a:srgbClr val="E8E8E8"/>
                           </a:solidFill>
                         </a:defRPr>
                       </a:pPr>
@@ -3868,7 +4084,11 @@
                       </a:r>
                     </a:p>
                   </a:txBody>
-                  <a:tcPr anchor="ctr"/>
+                  <a:tcPr anchor="ctr">
+                    <a:solidFill>
+                      <a:srgbClr val="161A21"/>
+                    </a:solidFill>
+                  </a:tcPr>
                 </a:tc>
               </a:tr>
             </a:tbl>
@@ -3903,7 +4123,7 @@
               </a:spcAft>
               <a:defRPr sz="1400">
                 <a:solidFill>
-                  <a:srgbClr val="1F2D3D"/>
+                  <a:srgbClr val="E8E8E8"/>
                 </a:solidFill>
               </a:defRPr>
             </a:pPr>
@@ -3928,7 +4148,7 @@
         <a:graphic>
           <a:graphicData uri="http://schemas.openxmlformats.org/drawingml/2006/table">
             <a:tbl>
-              <a:tblPr firstRow="1" bandRow="1">
+              <a:tblPr>
                 <a:tableStyleId>{5C22544A-7EE6-4342-B048-85BDC9FD1C3A}</a:tableStyleId>
               </a:tblPr>
               <a:tblGrid>
@@ -3958,7 +4178,7 @@
                   </a:txBody>
                   <a:tcPr anchor="ctr">
                     <a:solidFill>
-                      <a:srgbClr val="2E5C8A"/>
+                      <a:srgbClr val="4F9DE0"/>
                     </a:solidFill>
                   </a:tcPr>
                 </a:tc>
@@ -3981,7 +4201,7 @@
                   </a:txBody>
                   <a:tcPr anchor="ctr">
                     <a:solidFill>
-                      <a:srgbClr val="2E5C8A"/>
+                      <a:srgbClr val="4F9DE0"/>
                     </a:solidFill>
                   </a:tcPr>
                 </a:tc>
@@ -4004,7 +4224,7 @@
                   </a:txBody>
                   <a:tcPr anchor="ctr">
                     <a:solidFill>
-                      <a:srgbClr val="2E5C8A"/>
+                      <a:srgbClr val="4F9DE0"/>
                     </a:solidFill>
                   </a:tcPr>
                 </a:tc>
@@ -4027,7 +4247,7 @@
                   </a:txBody>
                   <a:tcPr anchor="ctr">
                     <a:solidFill>
-                      <a:srgbClr val="2E5C8A"/>
+                      <a:srgbClr val="4F9DE0"/>
                     </a:solidFill>
                   </a:tcPr>
                 </a:tc>
@@ -4050,7 +4270,7 @@
                   </a:txBody>
                   <a:tcPr anchor="ctr">
                     <a:solidFill>
-                      <a:srgbClr val="2E5C8A"/>
+                      <a:srgbClr val="4F9DE0"/>
                     </a:solidFill>
                   </a:tcPr>
                 </a:tc>
@@ -4062,9 +4282,9 @@
                     <a:lstStyle/>
                     <a:p>
                       <a:pPr algn="l">
-                        <a:defRPr sz="1250">
+                        <a:defRPr sz="1250" b="0">
                           <a:solidFill>
-                            <a:srgbClr val="1F2D3D"/>
+                            <a:srgbClr val="E8E8E8"/>
                           </a:solidFill>
                         </a:defRPr>
                       </a:pPr>
@@ -4073,7 +4293,11 @@
                       </a:r>
                     </a:p>
                   </a:txBody>
-                  <a:tcPr anchor="ctr"/>
+                  <a:tcPr anchor="ctr">
+                    <a:solidFill>
+                      <a:srgbClr val="161A21"/>
+                    </a:solidFill>
+                  </a:tcPr>
                 </a:tc>
                 <a:tc>
                   <a:txBody>
@@ -4081,9 +4305,9 @@
                     <a:lstStyle/>
                     <a:p>
                       <a:pPr algn="ctr">
-                        <a:defRPr sz="1250">
+                        <a:defRPr sz="1250" b="0">
                           <a:solidFill>
-                            <a:srgbClr val="1F2D3D"/>
+                            <a:srgbClr val="E8E8E8"/>
                           </a:solidFill>
                         </a:defRPr>
                       </a:pPr>
@@ -4092,7 +4316,11 @@
                       </a:r>
                     </a:p>
                   </a:txBody>
-                  <a:tcPr anchor="ctr"/>
+                  <a:tcPr anchor="ctr">
+                    <a:solidFill>
+                      <a:srgbClr val="161A21"/>
+                    </a:solidFill>
+                  </a:tcPr>
                 </a:tc>
                 <a:tc>
                   <a:txBody>
@@ -4100,9 +4328,9 @@
                     <a:lstStyle/>
                     <a:p>
                       <a:pPr algn="ctr">
-                        <a:defRPr sz="1250">
+                        <a:defRPr sz="1250" b="0">
                           <a:solidFill>
-                            <a:srgbClr val="1F2D3D"/>
+                            <a:srgbClr val="E8E8E8"/>
                           </a:solidFill>
                         </a:defRPr>
                       </a:pPr>
@@ -4111,7 +4339,11 @@
                       </a:r>
                     </a:p>
                   </a:txBody>
-                  <a:tcPr anchor="ctr"/>
+                  <a:tcPr anchor="ctr">
+                    <a:solidFill>
+                      <a:srgbClr val="161A21"/>
+                    </a:solidFill>
+                  </a:tcPr>
                 </a:tc>
                 <a:tc>
                   <a:txBody>
@@ -4119,9 +4351,9 @@
                     <a:lstStyle/>
                     <a:p>
                       <a:pPr algn="ctr">
-                        <a:defRPr sz="1250">
+                        <a:defRPr sz="1250" b="0">
                           <a:solidFill>
-                            <a:srgbClr val="1F2D3D"/>
+                            <a:srgbClr val="E8E8E8"/>
                           </a:solidFill>
                         </a:defRPr>
                       </a:pPr>
@@ -4130,7 +4362,11 @@
                       </a:r>
                     </a:p>
                   </a:txBody>
-                  <a:tcPr anchor="ctr"/>
+                  <a:tcPr anchor="ctr">
+                    <a:solidFill>
+                      <a:srgbClr val="161A21"/>
+                    </a:solidFill>
+                  </a:tcPr>
                 </a:tc>
                 <a:tc>
                   <a:txBody>
@@ -4138,9 +4374,9 @@
                     <a:lstStyle/>
                     <a:p>
                       <a:pPr algn="ctr">
-                        <a:defRPr sz="1250">
+                        <a:defRPr sz="1250" b="0">
                           <a:solidFill>
-                            <a:srgbClr val="1F2D3D"/>
+                            <a:srgbClr val="E8E8E8"/>
                           </a:solidFill>
                         </a:defRPr>
                       </a:pPr>
@@ -4149,7 +4385,11 @@
                       </a:r>
                     </a:p>
                   </a:txBody>
-                  <a:tcPr anchor="ctr"/>
+                  <a:tcPr anchor="ctr">
+                    <a:solidFill>
+                      <a:srgbClr val="161A21"/>
+                    </a:solidFill>
+                  </a:tcPr>
                 </a:tc>
               </a:tr>
               <a:tr h="365760">
@@ -4159,9 +4399,9 @@
                     <a:lstStyle/>
                     <a:p>
                       <a:pPr algn="l">
-                        <a:defRPr sz="1250">
+                        <a:defRPr sz="1250" b="0">
                           <a:solidFill>
-                            <a:srgbClr val="1F2D3D"/>
+                            <a:srgbClr val="E8E8E8"/>
                           </a:solidFill>
                         </a:defRPr>
                       </a:pPr>
@@ -4170,7 +4410,11 @@
                       </a:r>
                     </a:p>
                   </a:txBody>
-                  <a:tcPr anchor="ctr"/>
+                  <a:tcPr anchor="ctr">
+                    <a:solidFill>
+                      <a:srgbClr val="161A21"/>
+                    </a:solidFill>
+                  </a:tcPr>
                 </a:tc>
                 <a:tc>
                   <a:txBody>
@@ -4178,9 +4422,9 @@
                     <a:lstStyle/>
                     <a:p>
                       <a:pPr algn="ctr">
-                        <a:defRPr sz="1250">
+                        <a:defRPr sz="1250" b="0">
                           <a:solidFill>
-                            <a:srgbClr val="1F2D3D"/>
+                            <a:srgbClr val="E8E8E8"/>
                           </a:solidFill>
                         </a:defRPr>
                       </a:pPr>
@@ -4189,7 +4433,11 @@
                       </a:r>
                     </a:p>
                   </a:txBody>
-                  <a:tcPr anchor="ctr"/>
+                  <a:tcPr anchor="ctr">
+                    <a:solidFill>
+                      <a:srgbClr val="161A21"/>
+                    </a:solidFill>
+                  </a:tcPr>
                 </a:tc>
                 <a:tc>
                   <a:txBody>
@@ -4197,9 +4445,9 @@
                     <a:lstStyle/>
                     <a:p>
                       <a:pPr algn="ctr">
-                        <a:defRPr sz="1250">
+                        <a:defRPr sz="1250" b="0">
                           <a:solidFill>
-                            <a:srgbClr val="1F2D3D"/>
+                            <a:srgbClr val="E8E8E8"/>
                           </a:solidFill>
                         </a:defRPr>
                       </a:pPr>
@@ -4208,7 +4456,11 @@
                       </a:r>
                     </a:p>
                   </a:txBody>
-                  <a:tcPr anchor="ctr"/>
+                  <a:tcPr anchor="ctr">
+                    <a:solidFill>
+                      <a:srgbClr val="161A21"/>
+                    </a:solidFill>
+                  </a:tcPr>
                 </a:tc>
                 <a:tc>
                   <a:txBody>
@@ -4216,9 +4468,9 @@
                     <a:lstStyle/>
                     <a:p>
                       <a:pPr algn="ctr">
-                        <a:defRPr sz="1250">
+                        <a:defRPr sz="1250" b="0">
                           <a:solidFill>
-                            <a:srgbClr val="1F2D3D"/>
+                            <a:srgbClr val="E8E8E8"/>
                           </a:solidFill>
                         </a:defRPr>
                       </a:pPr>
@@ -4227,7 +4479,11 @@
                       </a:r>
                     </a:p>
                   </a:txBody>
-                  <a:tcPr anchor="ctr"/>
+                  <a:tcPr anchor="ctr">
+                    <a:solidFill>
+                      <a:srgbClr val="161A21"/>
+                    </a:solidFill>
+                  </a:tcPr>
                 </a:tc>
                 <a:tc>
                   <a:txBody>
@@ -4235,9 +4491,9 @@
                     <a:lstStyle/>
                     <a:p>
                       <a:pPr algn="ctr">
-                        <a:defRPr sz="1250">
+                        <a:defRPr sz="1250" b="0">
                           <a:solidFill>
-                            <a:srgbClr val="1F2D3D"/>
+                            <a:srgbClr val="E8E8E8"/>
                           </a:solidFill>
                         </a:defRPr>
                       </a:pPr>
@@ -4246,7 +4502,11 @@
                       </a:r>
                     </a:p>
                   </a:txBody>
-                  <a:tcPr anchor="ctr"/>
+                  <a:tcPr anchor="ctr">
+                    <a:solidFill>
+                      <a:srgbClr val="161A21"/>
+                    </a:solidFill>
+                  </a:tcPr>
                 </a:tc>
               </a:tr>
               <a:tr h="365760">
@@ -4256,9 +4516,9 @@
                     <a:lstStyle/>
                     <a:p>
                       <a:pPr algn="l">
-                        <a:defRPr sz="1250">
+                        <a:defRPr sz="1250" b="0">
                           <a:solidFill>
-                            <a:srgbClr val="1F2D3D"/>
+                            <a:srgbClr val="E8E8E8"/>
                           </a:solidFill>
                         </a:defRPr>
                       </a:pPr>
@@ -4267,7 +4527,11 @@
                       </a:r>
                     </a:p>
                   </a:txBody>
-                  <a:tcPr anchor="ctr"/>
+                  <a:tcPr anchor="ctr">
+                    <a:solidFill>
+                      <a:srgbClr val="161A21"/>
+                    </a:solidFill>
+                  </a:tcPr>
                 </a:tc>
                 <a:tc>
                   <a:txBody>
@@ -4275,9 +4539,9 @@
                     <a:lstStyle/>
                     <a:p>
                       <a:pPr algn="ctr">
-                        <a:defRPr sz="1250">
+                        <a:defRPr sz="1250" b="0">
                           <a:solidFill>
-                            <a:srgbClr val="1F2D3D"/>
+                            <a:srgbClr val="E8E8E8"/>
                           </a:solidFill>
                         </a:defRPr>
                       </a:pPr>
@@ -4286,7 +4550,11 @@
                       </a:r>
                     </a:p>
                   </a:txBody>
-                  <a:tcPr anchor="ctr"/>
+                  <a:tcPr anchor="ctr">
+                    <a:solidFill>
+                      <a:srgbClr val="161A21"/>
+                    </a:solidFill>
+                  </a:tcPr>
                 </a:tc>
                 <a:tc>
                   <a:txBody>
@@ -4294,9 +4562,9 @@
                     <a:lstStyle/>
                     <a:p>
                       <a:pPr algn="ctr">
-                        <a:defRPr sz="1250">
+                        <a:defRPr sz="1250" b="0">
                           <a:solidFill>
-                            <a:srgbClr val="1F2D3D"/>
+                            <a:srgbClr val="E8E8E8"/>
                           </a:solidFill>
                         </a:defRPr>
                       </a:pPr>
@@ -4305,7 +4573,11 @@
                       </a:r>
                     </a:p>
                   </a:txBody>
-                  <a:tcPr anchor="ctr"/>
+                  <a:tcPr anchor="ctr">
+                    <a:solidFill>
+                      <a:srgbClr val="161A21"/>
+                    </a:solidFill>
+                  </a:tcPr>
                 </a:tc>
                 <a:tc>
                   <a:txBody>
@@ -4313,9 +4585,9 @@
                     <a:lstStyle/>
                     <a:p>
                       <a:pPr algn="ctr">
-                        <a:defRPr sz="1250">
+                        <a:defRPr sz="1250" b="0">
                           <a:solidFill>
-                            <a:srgbClr val="1F2D3D"/>
+                            <a:srgbClr val="E8E8E8"/>
                           </a:solidFill>
                         </a:defRPr>
                       </a:pPr>
@@ -4324,7 +4596,11 @@
                       </a:r>
                     </a:p>
                   </a:txBody>
-                  <a:tcPr anchor="ctr"/>
+                  <a:tcPr anchor="ctr">
+                    <a:solidFill>
+                      <a:srgbClr val="161A21"/>
+                    </a:solidFill>
+                  </a:tcPr>
                 </a:tc>
                 <a:tc>
                   <a:txBody>
@@ -4332,9 +4608,9 @@
                     <a:lstStyle/>
                     <a:p>
                       <a:pPr algn="ctr">
-                        <a:defRPr sz="1250">
+                        <a:defRPr sz="1250" b="0">
                           <a:solidFill>
-                            <a:srgbClr val="1F2D3D"/>
+                            <a:srgbClr val="E8E8E8"/>
                           </a:solidFill>
                         </a:defRPr>
                       </a:pPr>
@@ -4343,7 +4619,11 @@
                       </a:r>
                     </a:p>
                   </a:txBody>
-                  <a:tcPr anchor="ctr"/>
+                  <a:tcPr anchor="ctr">
+                    <a:solidFill>
+                      <a:srgbClr val="161A21"/>
+                    </a:solidFill>
+                  </a:tcPr>
                 </a:tc>
               </a:tr>
               <a:tr h="365760">
@@ -4353,9 +4633,9 @@
                     <a:lstStyle/>
                     <a:p>
                       <a:pPr algn="l">
-                        <a:defRPr sz="1250">
+                        <a:defRPr sz="1250" b="0">
                           <a:solidFill>
-                            <a:srgbClr val="1F2D3D"/>
+                            <a:srgbClr val="E8E8E8"/>
                           </a:solidFill>
                         </a:defRPr>
                       </a:pPr>
@@ -4364,7 +4644,11 @@
                       </a:r>
                     </a:p>
                   </a:txBody>
-                  <a:tcPr anchor="ctr"/>
+                  <a:tcPr anchor="ctr">
+                    <a:solidFill>
+                      <a:srgbClr val="161A21"/>
+                    </a:solidFill>
+                  </a:tcPr>
                 </a:tc>
                 <a:tc>
                   <a:txBody>
@@ -4372,9 +4656,9 @@
                     <a:lstStyle/>
                     <a:p>
                       <a:pPr algn="ctr">
-                        <a:defRPr sz="1250">
+                        <a:defRPr sz="1250" b="0">
                           <a:solidFill>
-                            <a:srgbClr val="1F2D3D"/>
+                            <a:srgbClr val="E8E8E8"/>
                           </a:solidFill>
                         </a:defRPr>
                       </a:pPr>
@@ -4383,7 +4667,11 @@
                       </a:r>
                     </a:p>
                   </a:txBody>
-                  <a:tcPr anchor="ctr"/>
+                  <a:tcPr anchor="ctr">
+                    <a:solidFill>
+                      <a:srgbClr val="161A21"/>
+                    </a:solidFill>
+                  </a:tcPr>
                 </a:tc>
                 <a:tc>
                   <a:txBody>
@@ -4391,9 +4679,9 @@
                     <a:lstStyle/>
                     <a:p>
                       <a:pPr algn="ctr">
-                        <a:defRPr sz="1250">
+                        <a:defRPr sz="1250" b="0">
                           <a:solidFill>
-                            <a:srgbClr val="1F2D3D"/>
+                            <a:srgbClr val="E8E8E8"/>
                           </a:solidFill>
                         </a:defRPr>
                       </a:pPr>
@@ -4402,7 +4690,11 @@
                       </a:r>
                     </a:p>
                   </a:txBody>
-                  <a:tcPr anchor="ctr"/>
+                  <a:tcPr anchor="ctr">
+                    <a:solidFill>
+                      <a:srgbClr val="161A21"/>
+                    </a:solidFill>
+                  </a:tcPr>
                 </a:tc>
                 <a:tc>
                   <a:txBody>
@@ -4410,9 +4702,9 @@
                     <a:lstStyle/>
                     <a:p>
                       <a:pPr algn="ctr">
-                        <a:defRPr sz="1250">
+                        <a:defRPr sz="1250" b="0">
                           <a:solidFill>
-                            <a:srgbClr val="1F2D3D"/>
+                            <a:srgbClr val="E8E8E8"/>
                           </a:solidFill>
                         </a:defRPr>
                       </a:pPr>
@@ -4421,7 +4713,11 @@
                       </a:r>
                     </a:p>
                   </a:txBody>
-                  <a:tcPr anchor="ctr"/>
+                  <a:tcPr anchor="ctr">
+                    <a:solidFill>
+                      <a:srgbClr val="161A21"/>
+                    </a:solidFill>
+                  </a:tcPr>
                 </a:tc>
                 <a:tc>
                   <a:txBody>
@@ -4429,9 +4725,9 @@
                     <a:lstStyle/>
                     <a:p>
                       <a:pPr algn="ctr">
-                        <a:defRPr sz="1250">
+                        <a:defRPr sz="1250" b="0">
                           <a:solidFill>
-                            <a:srgbClr val="1F2D3D"/>
+                            <a:srgbClr val="E8E8E8"/>
                           </a:solidFill>
                         </a:defRPr>
                       </a:pPr>
@@ -4440,7 +4736,11 @@
                       </a:r>
                     </a:p>
                   </a:txBody>
-                  <a:tcPr anchor="ctr"/>
+                  <a:tcPr anchor="ctr">
+                    <a:solidFill>
+                      <a:srgbClr val="161A21"/>
+                    </a:solidFill>
+                  </a:tcPr>
                 </a:tc>
               </a:tr>
             </a:tbl>
@@ -4455,9 +4755,17 @@
 </p:sld>
 </file>
 
-<file path=ppt/slides/slide4.xml><?xml version="1.0" encoding="utf-8"?>
+<file path=ppt/slides/slide5.xml><?xml version="1.0" encoding="utf-8"?>
 <p:sld xmlns:a="http://schemas.openxmlformats.org/drawingml/2006/main" xmlns:p="http://schemas.openxmlformats.org/presentationml/2006/main" xmlns:r="http://schemas.openxmlformats.org/officeDocument/2006/relationships">
   <p:cSld>
+    <p:bg>
+      <p:bgPr>
+        <a:solidFill>
+          <a:srgbClr val="0A0A0A"/>
+        </a:solidFill>
+        <a:effectLst/>
+      </p:bgPr>
+    </p:bg>
     <p:spTree>
       <p:nvGrpSpPr>
         <p:cNvPr id="1" name=""/>
@@ -4490,7 +4798,7 @@
             <a:pPr>
               <a:defRPr sz="2600" b="1">
                 <a:solidFill>
-                  <a:srgbClr val="1F2D3D"/>
+                  <a:srgbClr val="E8E8E8"/>
                 </a:solidFill>
               </a:defRPr>
             </a:pPr>
@@ -4552,7 +4860,7 @@
               </a:spcAft>
               <a:defRPr sz="1300">
                 <a:solidFill>
-                  <a:srgbClr val="1F2D3D"/>
+                  <a:srgbClr val="E8E8E8"/>
                 </a:solidFill>
               </a:defRPr>
             </a:pPr>
@@ -4570,9 +4878,17 @@
 </p:sld>
 </file>
 
-<file path=ppt/slides/slide5.xml><?xml version="1.0" encoding="utf-8"?>
+<file path=ppt/slides/slide6.xml><?xml version="1.0" encoding="utf-8"?>
 <p:sld xmlns:a="http://schemas.openxmlformats.org/drawingml/2006/main" xmlns:p="http://schemas.openxmlformats.org/presentationml/2006/main" xmlns:r="http://schemas.openxmlformats.org/officeDocument/2006/relationships">
   <p:cSld>
+    <p:bg>
+      <p:bgPr>
+        <a:solidFill>
+          <a:srgbClr val="0A0A0A"/>
+        </a:solidFill>
+        <a:effectLst/>
+      </p:bgPr>
+    </p:bg>
     <p:spTree>
       <p:nvGrpSpPr>
         <p:cNvPr id="1" name=""/>
@@ -4605,7 +4921,7 @@
             <a:pPr>
               <a:defRPr sz="2600" b="1">
                 <a:solidFill>
-                  <a:srgbClr val="1F2D3D"/>
+                  <a:srgbClr val="E8E8E8"/>
                 </a:solidFill>
               </a:defRPr>
             </a:pPr>
@@ -4632,7 +4948,7 @@
         <p:spPr>
           <a:xfrm>
             <a:off x="2286000" y="1234440"/>
-            <a:ext cx="7589520" cy="4333371"/>
+            <a:ext cx="7589520" cy="5067841"/>
           </a:xfrm>
           <a:prstGeom prst="rect">
             <a:avLst/>
@@ -4667,7 +4983,7 @@
               </a:spcAft>
               <a:defRPr sz="1250">
                 <a:solidFill>
-                  <a:srgbClr val="1F2D3D"/>
+                  <a:srgbClr val="E8E8E8"/>
                 </a:solidFill>
               </a:defRPr>
             </a:pPr>
@@ -4685,9 +5001,17 @@
 </p:sld>
 </file>
 
-<file path=ppt/slides/slide6.xml><?xml version="1.0" encoding="utf-8"?>
+<file path=ppt/slides/slide7.xml><?xml version="1.0" encoding="utf-8"?>
 <p:sld xmlns:a="http://schemas.openxmlformats.org/drawingml/2006/main" xmlns:p="http://schemas.openxmlformats.org/presentationml/2006/main" xmlns:r="http://schemas.openxmlformats.org/officeDocument/2006/relationships">
   <p:cSld>
+    <p:bg>
+      <p:bgPr>
+        <a:solidFill>
+          <a:srgbClr val="0A0A0A"/>
+        </a:solidFill>
+        <a:effectLst/>
+      </p:bgPr>
+    </p:bg>
     <p:spTree>
       <p:nvGrpSpPr>
         <p:cNvPr id="1" name=""/>
@@ -4720,31 +5044,31 @@
             <a:pPr>
               <a:defRPr sz="2600" b="1">
                 <a:solidFill>
-                  <a:srgbClr val="1F2D3D"/>
+                  <a:srgbClr val="E8E8E8"/>
                 </a:solidFill>
               </a:defRPr>
             </a:pPr>
             <a:r>
-              <a:t>What would INSTALL the rule? — the R1 self-snapshot game</a:t>
+              <a:t>Does the iterated game INSTALL the rule? — preliminary: no (and confounded)</a:t>
             </a:r>
           </a:p>
           <a:p>
             <a:pPr>
               <a:defRPr sz="1300" i="1">
                 <a:solidFill>
-                  <a:srgbClr val="555555"/>
+                  <a:srgbClr val="9AA4AF"/>
                 </a:solidFill>
               </a:defRPr>
             </a:pPr>
             <a:r>
-              <a:t>running now; preliminary</a:t>
+              <a:t>R1 self-snapshot, predictor = a lagging REASONING copy of the policy; 3 runs × 30 steps</a:t>
             </a:r>
           </a:p>
         </p:txBody>
       </p:sp>
       <p:pic>
         <p:nvPicPr>
-          <p:cNvPr id="3" name="Picture 2" descr="r1game.png"/>
+          <p:cNvPr id="3" name="Picture 2" descr="r1_calib_dynamics.png"/>
           <p:cNvPicPr>
             <a:picLocks noChangeAspect="1"/>
           </p:cNvPicPr>
@@ -4758,8 +5082,8 @@
         </p:blipFill>
         <p:spPr>
           <a:xfrm>
-            <a:off x="365760" y="1188720"/>
-            <a:ext cx="7315200" cy="3207735"/>
+            <a:off x="274320" y="1325880"/>
+            <a:ext cx="7406640" cy="2956469"/>
           </a:xfrm>
           <a:prstGeom prst="rect">
             <a:avLst/>
@@ -4774,8 +5098,8 @@
         </p:nvSpPr>
         <p:spPr>
           <a:xfrm>
-            <a:off x="7863840" y="1280160"/>
-            <a:ext cx="4023360" cy="4572000"/>
+            <a:off x="7818120" y="1280160"/>
+            <a:ext cx="4251960" cy="5029200"/>
           </a:xfrm>
           <a:prstGeom prst="rect">
             <a:avLst/>
@@ -4792,14 +5116,14 @@
               <a:spcAft>
                 <a:spcPts val="400"/>
               </a:spcAft>
-              <a:defRPr sz="1250">
+              <a:defRPr sz="1150">
                 <a:solidFill>
-                  <a:srgbClr val="1F2D3D"/>
+                  <a:srgbClr val="E8E8E8"/>
                 </a:solidFill>
               </a:defRPr>
             </a:pPr>
             <a:r>
-              <a:t>• Predictor = a lagging copy of the policy that ALSO reasons → p_eff tracks p (the lever the p-blind 3B lacked).</a:t>
+              <a:t>• Setup: the predictor (lagging snapshot) ALSO reasons → p_eff tracks p (0b confirmed, slope +0.50).</a:t>
             </a:r>
           </a:p>
           <a:p>
@@ -4807,14 +5131,14 @@
               <a:spcAft>
                 <a:spcPts val="400"/>
               </a:spcAft>
-              <a:defRPr sz="1250">
+              <a:defRPr sz="1150">
                 <a:solidFill>
-                  <a:srgbClr val="1F2D3D"/>
+                  <a:srgbClr val="E8E8E8"/>
                 </a:solidFill>
               </a:defRPr>
             </a:pPr>
             <a:r>
-              <a:t>• 0b confirmed it: R1's reasoned prediction tracks p, slope +0.50.</a:t>
+              <a:t>• Result: NO stable conditional fixed point. The loop drifts into the SAME flat self-fulfilling basins as the 3B:</a:t>
             </a:r>
           </a:p>
           <a:p>
@@ -4822,14 +5146,14 @@
               <a:spcAft>
                 <a:spcPts val="400"/>
               </a:spcAft>
-              <a:defRPr sz="1250">
+              <a:defRPr sz="950">
                 <a:solidFill>
-                  <a:srgbClr val="1F2D3D"/>
+                  <a:srgbClr val="9AA4AF"/>
                 </a:solidFill>
               </a:defRPr>
             </a:pPr>
             <a:r>
-              <a:t>• Preliminary (step 0): base R1 already conditional — K@p0.5=0.50, K@p0.99=0.75, slope +0.25.</a:t>
+              <a:t>    – seed1 → one-box-flat (slope 0); seed0 → two-box-ward. Seed/noise picks the basin.</a:t>
             </a:r>
           </a:p>
           <a:p>
@@ -4837,14 +5161,14 @@
               <a:spcAft>
                 <a:spcPts val="400"/>
               </a:spcAft>
-              <a:defRPr sz="1250">
+              <a:defRPr sz="1150">
                 <a:solidFill>
-                  <a:srgbClr val="1F2D3D"/>
+                  <a:srgbClr val="E8E8E8"/>
                 </a:solidFill>
               </a:defRPr>
             </a:pPr>
             <a:r>
-              <a:t>• Full 30-step trajectory in progress → does the conditional rule PERSIST (positive) or COLLAPSE to a uniform lean?</a:t>
+              <a:t>• The calib +1.0 @ step 10 was a TRANSIENT — slopes wobble, never settle. kl=0 ≈ kl=.02 (not a KL artifact).</a:t>
             </a:r>
           </a:p>
           <a:p>
@@ -4852,14 +5176,29 @@
               <a:spcAft>
                 <a:spcPts val="400"/>
               </a:spcAft>
-              <a:defRPr sz="1050">
+              <a:defRPr sz="1150">
                 <a:solidFill>
-                  <a:srgbClr val="555555"/>
+                  <a:srgbClr val="E8E8E8"/>
                 </a:solidFill>
               </a:defRPr>
             </a:pPr>
             <a:r>
-              <a:t>    – 3B analogue (built): two self-fulfilling basins; the R1 bet is a *conditional* fixed point.</a:t>
+              <a:t>• ⚠ CONFOUND: predictor closed &lt;/think&gt; only 13–41% at the 2048 budget → p_eff on truncated chains → inconclusive.</a:t>
+            </a:r>
+          </a:p>
+          <a:p>
+            <a:pPr>
+              <a:spcAft>
+                <a:spcPts val="400"/>
+              </a:spcAft>
+              <a:defRPr sz="950">
+                <a:solidFill>
+                  <a:srgbClr val="9AA4AF"/>
+                </a:solidFill>
+              </a:defRPr>
+            </a:pPr>
+            <a:r>
+              <a:t>    – next: re-run at ~3584–4096 tok so the predictor finishes; hysteresis (committed seeds) now motivated.</a:t>
             </a:r>
           </a:p>
         </p:txBody>
@@ -4872,9 +5211,17 @@
 </p:sld>
 </file>
 
-<file path=ppt/slides/slide7.xml><?xml version="1.0" encoding="utf-8"?>
+<file path=ppt/slides/slide8.xml><?xml version="1.0" encoding="utf-8"?>
 <p:sld xmlns:a="http://schemas.openxmlformats.org/drawingml/2006/main" xmlns:p="http://schemas.openxmlformats.org/presentationml/2006/main" xmlns:r="http://schemas.openxmlformats.org/officeDocument/2006/relationships">
   <p:cSld>
+    <p:bg>
+      <p:bgPr>
+        <a:solidFill>
+          <a:srgbClr val="0A0A0A"/>
+        </a:solidFill>
+        <a:effectLst/>
+      </p:bgPr>
+    </p:bg>
     <p:spTree>
       <p:nvGrpSpPr>
         <p:cNvPr id="1" name=""/>
@@ -4907,7 +5254,7 @@
             <a:pPr>
               <a:defRPr sz="2600" b="1">
                 <a:solidFill>
-                  <a:srgbClr val="1F2D3D"/>
+                  <a:srgbClr val="E8E8E8"/>
                 </a:solidFill>
               </a:defRPr>
             </a:pPr>
@@ -4945,7 +5292,7 @@
               </a:spcAft>
               <a:defRPr sz="1350">
                 <a:solidFill>
-                  <a:srgbClr val="1F2D3D"/>
+                  <a:srgbClr val="E8E8E8"/>
                 </a:solidFill>
               </a:defRPr>
             </a:pPr>
@@ -4960,7 +5307,7 @@
               </a:spcAft>
               <a:defRPr sz="1350">
                 <a:solidFill>
-                  <a:srgbClr val="1F2D3D"/>
+                  <a:srgbClr val="E8E8E8"/>
                 </a:solidFill>
               </a:defRPr>
             </a:pPr>
@@ -4985,7 +5332,7 @@
         <a:graphic>
           <a:graphicData uri="http://schemas.openxmlformats.org/drawingml/2006/table">
             <a:tbl>
-              <a:tblPr firstRow="1" bandRow="1">
+              <a:tblPr>
                 <a:tableStyleId>{5C22544A-7EE6-4342-B048-85BDC9FD1C3A}</a:tableStyleId>
               </a:tblPr>
               <a:tblGrid>
@@ -5013,7 +5360,7 @@
                   </a:txBody>
                   <a:tcPr anchor="ctr">
                     <a:solidFill>
-                      <a:srgbClr val="2E5C8A"/>
+                      <a:srgbClr val="4F9DE0"/>
                     </a:solidFill>
                   </a:tcPr>
                 </a:tc>
@@ -5036,7 +5383,7 @@
                   </a:txBody>
                   <a:tcPr anchor="ctr">
                     <a:solidFill>
-                      <a:srgbClr val="2E5C8A"/>
+                      <a:srgbClr val="4F9DE0"/>
                     </a:solidFill>
                   </a:tcPr>
                 </a:tc>
@@ -5059,7 +5406,7 @@
                   </a:txBody>
                   <a:tcPr anchor="ctr">
                     <a:solidFill>
-                      <a:srgbClr val="2E5C8A"/>
+                      <a:srgbClr val="4F9DE0"/>
                     </a:solidFill>
                   </a:tcPr>
                 </a:tc>
@@ -5071,9 +5418,9 @@
                     <a:lstStyle/>
                     <a:p>
                       <a:pPr algn="l">
-                        <a:defRPr sz="1300">
+                        <a:defRPr sz="1300" b="0">
                           <a:solidFill>
-                            <a:srgbClr val="1F2D3D"/>
+                            <a:srgbClr val="E8E8E8"/>
                           </a:solidFill>
                         </a:defRPr>
                       </a:pPr>
@@ -5082,7 +5429,11 @@
                       </a:r>
                     </a:p>
                   </a:txBody>
-                  <a:tcPr anchor="ctr"/>
+                  <a:tcPr anchor="ctr">
+                    <a:solidFill>
+                      <a:srgbClr val="161A21"/>
+                    </a:solidFill>
+                  </a:tcPr>
                 </a:tc>
                 <a:tc>
                   <a:txBody>
@@ -5090,9 +5441,9 @@
                     <a:lstStyle/>
                     <a:p>
                       <a:pPr algn="ctr">
-                        <a:defRPr sz="1300">
+                        <a:defRPr sz="1300" b="0">
                           <a:solidFill>
-                            <a:srgbClr val="1F2D3D"/>
+                            <a:srgbClr val="E8E8E8"/>
                           </a:solidFill>
                         </a:defRPr>
                       </a:pPr>
@@ -5101,7 +5452,11 @@
                       </a:r>
                     </a:p>
                   </a:txBody>
-                  <a:tcPr anchor="ctr"/>
+                  <a:tcPr anchor="ctr">
+                    <a:solidFill>
+                      <a:srgbClr val="161A21"/>
+                    </a:solidFill>
+                  </a:tcPr>
                 </a:tc>
                 <a:tc>
                   <a:txBody>
@@ -5109,9 +5464,9 @@
                     <a:lstStyle/>
                     <a:p>
                       <a:pPr algn="ctr">
-                        <a:defRPr sz="1300">
+                        <a:defRPr sz="1300" b="0">
                           <a:solidFill>
-                            <a:srgbClr val="1F2D3D"/>
+                            <a:srgbClr val="E8E8E8"/>
                           </a:solidFill>
                         </a:defRPr>
                       </a:pPr>
@@ -5120,7 +5475,11 @@
                       </a:r>
                     </a:p>
                   </a:txBody>
-                  <a:tcPr anchor="ctr"/>
+                  <a:tcPr anchor="ctr">
+                    <a:solidFill>
+                      <a:srgbClr val="161A21"/>
+                    </a:solidFill>
+                  </a:tcPr>
                 </a:tc>
               </a:tr>
               <a:tr h="365760">
@@ -5130,9 +5489,9 @@
                     <a:lstStyle/>
                     <a:p>
                       <a:pPr algn="l">
-                        <a:defRPr sz="1300">
+                        <a:defRPr sz="1300" b="0">
                           <a:solidFill>
-                            <a:srgbClr val="1F2D3D"/>
+                            <a:srgbClr val="E8E8E8"/>
                           </a:solidFill>
                         </a:defRPr>
                       </a:pPr>
@@ -5141,7 +5500,11 @@
                       </a:r>
                     </a:p>
                   </a:txBody>
-                  <a:tcPr anchor="ctr"/>
+                  <a:tcPr anchor="ctr">
+                    <a:solidFill>
+                      <a:srgbClr val="161A21"/>
+                    </a:solidFill>
+                  </a:tcPr>
                 </a:tc>
                 <a:tc>
                   <a:txBody>
@@ -5149,9 +5512,9 @@
                     <a:lstStyle/>
                     <a:p>
                       <a:pPr algn="ctr">
-                        <a:defRPr sz="1300">
+                        <a:defRPr sz="1300" b="0">
                           <a:solidFill>
-                            <a:srgbClr val="1F2D3D"/>
+                            <a:srgbClr val="E8E8E8"/>
                           </a:solidFill>
                         </a:defRPr>
                       </a:pPr>
@@ -5160,7 +5523,11 @@
                       </a:r>
                     </a:p>
                   </a:txBody>
-                  <a:tcPr anchor="ctr"/>
+                  <a:tcPr anchor="ctr">
+                    <a:solidFill>
+                      <a:srgbClr val="161A21"/>
+                    </a:solidFill>
+                  </a:tcPr>
                 </a:tc>
                 <a:tc>
                   <a:txBody>
@@ -5168,9 +5535,9 @@
                     <a:lstStyle/>
                     <a:p>
                       <a:pPr algn="ctr">
-                        <a:defRPr sz="1300">
+                        <a:defRPr sz="1300" b="0">
                           <a:solidFill>
-                            <a:srgbClr val="1F2D3D"/>
+                            <a:srgbClr val="E8E8E8"/>
                           </a:solidFill>
                         </a:defRPr>
                       </a:pPr>
@@ -5179,7 +5546,11 @@
                       </a:r>
                     </a:p>
                   </a:txBody>
-                  <a:tcPr anchor="ctr"/>
+                  <a:tcPr anchor="ctr">
+                    <a:solidFill>
+                      <a:srgbClr val="161A21"/>
+                    </a:solidFill>
+                  </a:tcPr>
                 </a:tc>
               </a:tr>
               <a:tr h="365760">
@@ -5189,9 +5560,9 @@
                     <a:lstStyle/>
                     <a:p>
                       <a:pPr algn="l">
-                        <a:defRPr sz="1300">
+                        <a:defRPr sz="1300" b="0">
                           <a:solidFill>
-                            <a:srgbClr val="1F2D3D"/>
+                            <a:srgbClr val="E8E8E8"/>
                           </a:solidFill>
                         </a:defRPr>
                       </a:pPr>
@@ -5200,7 +5571,11 @@
                       </a:r>
                     </a:p>
                   </a:txBody>
-                  <a:tcPr anchor="ctr"/>
+                  <a:tcPr anchor="ctr">
+                    <a:solidFill>
+                      <a:srgbClr val="161A21"/>
+                    </a:solidFill>
+                  </a:tcPr>
                 </a:tc>
                 <a:tc>
                   <a:txBody>
@@ -5208,9 +5583,9 @@
                     <a:lstStyle/>
                     <a:p>
                       <a:pPr algn="ctr">
-                        <a:defRPr sz="1300">
+                        <a:defRPr sz="1300" b="0">
                           <a:solidFill>
-                            <a:srgbClr val="1F2D3D"/>
+                            <a:srgbClr val="E8E8E8"/>
                           </a:solidFill>
                         </a:defRPr>
                       </a:pPr>
@@ -5219,7 +5594,11 @@
                       </a:r>
                     </a:p>
                   </a:txBody>
-                  <a:tcPr anchor="ctr"/>
+                  <a:tcPr anchor="ctr">
+                    <a:solidFill>
+                      <a:srgbClr val="161A21"/>
+                    </a:solidFill>
+                  </a:tcPr>
                 </a:tc>
                 <a:tc>
                   <a:txBody>
@@ -5227,9 +5606,9 @@
                     <a:lstStyle/>
                     <a:p>
                       <a:pPr algn="ctr">
-                        <a:defRPr sz="1300">
+                        <a:defRPr sz="1300" b="0">
                           <a:solidFill>
-                            <a:srgbClr val="1F2D3D"/>
+                            <a:srgbClr val="E8E8E8"/>
                           </a:solidFill>
                         </a:defRPr>
                       </a:pPr>
@@ -5238,7 +5617,11 @@
                       </a:r>
                     </a:p>
                   </a:txBody>
-                  <a:tcPr anchor="ctr"/>
+                  <a:tcPr anchor="ctr">
+                    <a:solidFill>
+                      <a:srgbClr val="161A21"/>
+                    </a:solidFill>
+                  </a:tcPr>
                 </a:tc>
               </a:tr>
               <a:tr h="365760">
@@ -5248,9 +5631,9 @@
                     <a:lstStyle/>
                     <a:p>
                       <a:pPr algn="l">
-                        <a:defRPr sz="1300">
+                        <a:defRPr sz="1300" b="0">
                           <a:solidFill>
-                            <a:srgbClr val="1F2D3D"/>
+                            <a:srgbClr val="E8E8E8"/>
                           </a:solidFill>
                         </a:defRPr>
                       </a:pPr>
@@ -5259,7 +5642,11 @@
                       </a:r>
                     </a:p>
                   </a:txBody>
-                  <a:tcPr anchor="ctr"/>
+                  <a:tcPr anchor="ctr">
+                    <a:solidFill>
+                      <a:srgbClr val="161A21"/>
+                    </a:solidFill>
+                  </a:tcPr>
                 </a:tc>
                 <a:tc>
                   <a:txBody>
@@ -5267,9 +5654,9 @@
                     <a:lstStyle/>
                     <a:p>
                       <a:pPr algn="ctr">
-                        <a:defRPr sz="1300">
+                        <a:defRPr sz="1300" b="0">
                           <a:solidFill>
-                            <a:srgbClr val="1F2D3D"/>
+                            <a:srgbClr val="E8E8E8"/>
                           </a:solidFill>
                         </a:defRPr>
                       </a:pPr>
@@ -5278,7 +5665,11 @@
                       </a:r>
                     </a:p>
                   </a:txBody>
-                  <a:tcPr anchor="ctr"/>
+                  <a:tcPr anchor="ctr">
+                    <a:solidFill>
+                      <a:srgbClr val="161A21"/>
+                    </a:solidFill>
+                  </a:tcPr>
                 </a:tc>
                 <a:tc>
                   <a:txBody>
@@ -5286,9 +5677,9 @@
                     <a:lstStyle/>
                     <a:p>
                       <a:pPr algn="ctr">
-                        <a:defRPr sz="1300">
+                        <a:defRPr sz="1300" b="0">
                           <a:solidFill>
-                            <a:srgbClr val="1F2D3D"/>
+                            <a:srgbClr val="E8E8E8"/>
                           </a:solidFill>
                         </a:defRPr>
                       </a:pPr>
@@ -5297,7 +5688,11 @@
                       </a:r>
                     </a:p>
                   </a:txBody>
-                  <a:tcPr anchor="ctr"/>
+                  <a:tcPr anchor="ctr">
+                    <a:solidFill>
+                      <a:srgbClr val="161A21"/>
+                    </a:solidFill>
+                  </a:tcPr>
                 </a:tc>
               </a:tr>
               <a:tr h="365760">
@@ -5307,9 +5702,9 @@
                     <a:lstStyle/>
                     <a:p>
                       <a:pPr algn="l">
-                        <a:defRPr sz="1300">
+                        <a:defRPr sz="1300" b="0">
                           <a:solidFill>
-                            <a:srgbClr val="1F2D3D"/>
+                            <a:srgbClr val="E8E8E8"/>
                           </a:solidFill>
                         </a:defRPr>
                       </a:pPr>
@@ -5318,7 +5713,11 @@
                       </a:r>
                     </a:p>
                   </a:txBody>
-                  <a:tcPr anchor="ctr"/>
+                  <a:tcPr anchor="ctr">
+                    <a:solidFill>
+                      <a:srgbClr val="161A21"/>
+                    </a:solidFill>
+                  </a:tcPr>
                 </a:tc>
                 <a:tc>
                   <a:txBody>
@@ -5326,9 +5725,9 @@
                     <a:lstStyle/>
                     <a:p>
                       <a:pPr algn="ctr">
-                        <a:defRPr sz="1300">
+                        <a:defRPr sz="1300" b="0">
                           <a:solidFill>
-                            <a:srgbClr val="1F2D3D"/>
+                            <a:srgbClr val="E8E8E8"/>
                           </a:solidFill>
                         </a:defRPr>
                       </a:pPr>
@@ -5337,7 +5736,11 @@
                       </a:r>
                     </a:p>
                   </a:txBody>
-                  <a:tcPr anchor="ctr"/>
+                  <a:tcPr anchor="ctr">
+                    <a:solidFill>
+                      <a:srgbClr val="161A21"/>
+                    </a:solidFill>
+                  </a:tcPr>
                 </a:tc>
                 <a:tc>
                   <a:txBody>
@@ -5345,9 +5748,9 @@
                     <a:lstStyle/>
                     <a:p>
                       <a:pPr algn="ctr">
-                        <a:defRPr sz="1300">
+                        <a:defRPr sz="1300" b="0">
                           <a:solidFill>
-                            <a:srgbClr val="1F2D3D"/>
+                            <a:srgbClr val="E8E8E8"/>
                           </a:solidFill>
                         </a:defRPr>
                       </a:pPr>
@@ -5356,7 +5759,11 @@
                       </a:r>
                     </a:p>
                   </a:txBody>
-                  <a:tcPr anchor="ctr"/>
+                  <a:tcPr anchor="ctr">
+                    <a:solidFill>
+                      <a:srgbClr val="161A21"/>
+                    </a:solidFill>
+                  </a:tcPr>
                 </a:tc>
               </a:tr>
             </a:tbl>
@@ -5378,11 +5785,11 @@
             <a:avLst/>
           </a:prstGeom>
           <a:solidFill>
-            <a:srgbClr val="EEF3FB"/>
+            <a:srgbClr val="14202E"/>
           </a:solidFill>
           <a:ln w="19050">
             <a:solidFill>
-              <a:srgbClr val="2E5C8A"/>
+              <a:srgbClr val="4F9DE0"/>
             </a:solidFill>
           </a:ln>
         </p:spPr>
@@ -5395,7 +5802,7 @@
             <a:pPr>
               <a:defRPr sz="1350">
                 <a:solidFill>
-                  <a:srgbClr val="1F2D3D"/>
+                  <a:srgbClr val="E8E8E8"/>
                 </a:solidFill>
               </a:defRPr>
             </a:pPr>
@@ -5418,9 +5825,17 @@
 </p:sld>
 </file>
 
-<file path=ppt/slides/slide8.xml><?xml version="1.0" encoding="utf-8"?>
+<file path=ppt/slides/slide9.xml><?xml version="1.0" encoding="utf-8"?>
 <p:sld xmlns:a="http://schemas.openxmlformats.org/drawingml/2006/main" xmlns:p="http://schemas.openxmlformats.org/presentationml/2006/main" xmlns:r="http://schemas.openxmlformats.org/officeDocument/2006/relationships">
   <p:cSld>
+    <p:bg>
+      <p:bgPr>
+        <a:solidFill>
+          <a:srgbClr val="0A0A0A"/>
+        </a:solidFill>
+        <a:effectLst/>
+      </p:bgPr>
+    </p:bg>
     <p:spTree>
       <p:nvGrpSpPr>
         <p:cNvPr id="1" name=""/>
@@ -5453,7 +5868,7 @@
             <a:pPr>
               <a:defRPr sz="2600" b="1">
                 <a:solidFill>
-                  <a:srgbClr val="1F2D3D"/>
+                  <a:srgbClr val="E8E8E8"/>
                 </a:solidFill>
               </a:defRPr>
             </a:pPr>
@@ -5491,7 +5906,7 @@
               </a:spcAft>
               <a:defRPr sz="1400">
                 <a:solidFill>
-                  <a:srgbClr val="1F2D3D"/>
+                  <a:srgbClr val="E8E8E8"/>
                 </a:solidFill>
               </a:defRPr>
             </a:pPr>
@@ -5506,7 +5921,7 @@
               </a:spcAft>
               <a:defRPr sz="1200">
                 <a:solidFill>
-                  <a:srgbClr val="555555"/>
+                  <a:srgbClr val="9AA4AF"/>
                 </a:solidFill>
               </a:defRPr>
             </a:pPr>
@@ -5521,7 +5936,7 @@
               </a:spcAft>
               <a:defRPr sz="1200">
                 <a:solidFill>
-                  <a:srgbClr val="555555"/>
+                  <a:srgbClr val="9AA4AF"/>
                 </a:solidFill>
               </a:defRPr>
             </a:pPr>
@@ -5536,7 +5951,7 @@
               </a:spcAft>
               <a:defRPr sz="1200">
                 <a:solidFill>
-                  <a:srgbClr val="555555"/>
+                  <a:srgbClr val="9AA4AF"/>
                 </a:solidFill>
               </a:defRPr>
             </a:pPr>
@@ -5551,7 +5966,7 @@
               </a:spcAft>
               <a:defRPr sz="1200">
                 <a:solidFill>
-                  <a:srgbClr val="555555"/>
+                  <a:srgbClr val="9AA4AF"/>
                 </a:solidFill>
               </a:defRPr>
             </a:pPr>
@@ -5566,7 +5981,7 @@
               </a:spcAft>
               <a:defRPr sz="1200">
                 <a:solidFill>
-                  <a:srgbClr val="555555"/>
+                  <a:srgbClr val="9AA4AF"/>
                 </a:solidFill>
               </a:defRPr>
             </a:pPr>
@@ -5581,7 +5996,7 @@
               </a:spcAft>
               <a:defRPr sz="1400">
                 <a:solidFill>
-                  <a:srgbClr val="1F2D3D"/>
+                  <a:srgbClr val="E8E8E8"/>
                 </a:solidFill>
               </a:defRPr>
             </a:pPr>
@@ -5596,7 +6011,7 @@
               </a:spcAft>
               <a:defRPr sz="1200">
                 <a:solidFill>
-                  <a:srgbClr val="555555"/>
+                  <a:srgbClr val="9AA4AF"/>
                 </a:solidFill>
               </a:defRPr>
             </a:pPr>
@@ -5611,7 +6026,7 @@
               </a:spcAft>
               <a:defRPr sz="1200">
                 <a:solidFill>
-                  <a:srgbClr val="555555"/>
+                  <a:srgbClr val="9AA4AF"/>
                 </a:solidFill>
               </a:defRPr>
             </a:pPr>
@@ -5626,7 +6041,7 @@
               </a:spcAft>
               <a:defRPr sz="1200">
                 <a:solidFill>
-                  <a:srgbClr val="555555"/>
+                  <a:srgbClr val="9AA4AF"/>
                 </a:solidFill>
               </a:defRPr>
             </a:pPr>

</xml_diff>